<commit_message>
Update app and presentation with latest changes
Co-Authored-By: Claude Haiku 4.5 <noreply@anthropic.com>
</commit_message>
<xml_diff>
--- a/documents/Image_Forgery_Detector_Presentation.pptx
+++ b/documents/Image_Forgery_Detector_Presentation.pptx
@@ -5,19 +5,19 @@
     <p:sldMasterId id="2147483648" r:id="rId1"/>
   </p:sldMasterIdLst>
   <p:sldIdLst>
-    <p:sldId id="256" r:id="rId7"/>
-    <p:sldId id="257" r:id="rId8"/>
-    <p:sldId id="258" r:id="rId9"/>
-    <p:sldId id="259" r:id="rId10"/>
-    <p:sldId id="260" r:id="rId11"/>
-    <p:sldId id="261" r:id="rId12"/>
-    <p:sldId id="262" r:id="rId13"/>
-    <p:sldId id="263" r:id="rId14"/>
-    <p:sldId id="264" r:id="rId15"/>
-    <p:sldId id="265" r:id="rId16"/>
-    <p:sldId id="266" r:id="rId17"/>
+    <p:sldId id="256" r:id="rId2"/>
+    <p:sldId id="257" r:id="rId3"/>
+    <p:sldId id="258" r:id="rId4"/>
+    <p:sldId id="259" r:id="rId5"/>
+    <p:sldId id="260" r:id="rId6"/>
+    <p:sldId id="261" r:id="rId7"/>
+    <p:sldId id="262" r:id="rId8"/>
+    <p:sldId id="263" r:id="rId9"/>
+    <p:sldId id="264" r:id="rId10"/>
+    <p:sldId id="265" r:id="rId11"/>
+    <p:sldId id="266" r:id="rId12"/>
   </p:sldIdLst>
-  <p:sldSz cx="12188952" cy="6858000" type="screen4x3"/>
+  <p:sldSz cx="12188825" cy="6858000"/>
   <p:notesSz cx="6858000" cy="9144000"/>
   <p:defaultTextStyle>
     <a:defPPr>
@@ -114,6 +114,22 @@
       </a:defRPr>
     </a:lvl9pPr>
   </p:defaultTextStyle>
+  <p:extLst>
+    <p:ext uri="{EFAFB233-063F-42B5-8137-9DF3F51BA10A}">
+      <p15:sldGuideLst xmlns:p15="http://schemas.microsoft.com/office/powerpoint/2012/main">
+        <p15:guide id="1" orient="horz" pos="2160">
+          <p15:clr>
+            <a:srgbClr val="A4A3A4"/>
+          </p15:clr>
+        </p15:guide>
+        <p15:guide id="2" pos="2880">
+          <p15:clr>
+            <a:srgbClr val="A4A3A4"/>
+          </p15:clr>
+        </p15:guide>
+      </p15:sldGuideLst>
+    </p:ext>
+  </p:extLst>
 </p:presentation>
 </file>
 
@@ -155,10 +171,9 @@
           <a:lstStyle/>
           <a:p>
             <a:r>
-              <a:rPr lang="en-US" smtClean="0"/>
+              <a:rPr lang="en-US"/>
               <a:t>Click to edit Master title style</a:t>
             </a:r>
-            <a:endParaRPr lang="en-US"/>
           </a:p>
         </p:txBody>
       </p:sp>
@@ -274,10 +289,9 @@
           </a:lstStyle>
           <a:p>
             <a:r>
-              <a:rPr lang="en-US" smtClean="0"/>
+              <a:rPr lang="en-US"/>
               <a:t>Click to edit Master subtitle style</a:t>
             </a:r>
-            <a:endParaRPr lang="en-US"/>
           </a:p>
         </p:txBody>
       </p:sp>
@@ -298,7 +312,7 @@
           <a:p>
             <a:fld id="{5BCAD085-E8A6-8845-BD4E-CB4CCA059FC4}" type="datetimeFigureOut">
               <a:rPr lang="en-US" smtClean="0"/>
-              <a:t>1/27/13</a:t>
+              <a:t>25-Jun-26</a:t>
             </a:fld>
             <a:endParaRPr lang="en-US"/>
           </a:p>
@@ -392,10 +406,9 @@
           <a:lstStyle/>
           <a:p>
             <a:r>
-              <a:rPr lang="en-US" smtClean="0"/>
+              <a:rPr lang="en-US"/>
               <a:t>Click to edit Master title style</a:t>
             </a:r>
-            <a:endParaRPr lang="en-US"/>
           </a:p>
         </p:txBody>
       </p:sp>
@@ -416,38 +429,37 @@
           <a:p>
             <a:pPr lvl="0"/>
             <a:r>
-              <a:rPr lang="en-US" smtClean="0"/>
+              <a:rPr lang="en-US"/>
               <a:t>Click to edit Master text styles</a:t>
             </a:r>
           </a:p>
           <a:p>
             <a:pPr lvl="1"/>
             <a:r>
-              <a:rPr lang="en-US" smtClean="0"/>
+              <a:rPr lang="en-US"/>
               <a:t>Second level</a:t>
             </a:r>
           </a:p>
           <a:p>
             <a:pPr lvl="2"/>
             <a:r>
-              <a:rPr lang="en-US" smtClean="0"/>
+              <a:rPr lang="en-US"/>
               <a:t>Third level</a:t>
             </a:r>
           </a:p>
           <a:p>
             <a:pPr lvl="3"/>
             <a:r>
-              <a:rPr lang="en-US" smtClean="0"/>
+              <a:rPr lang="en-US"/>
               <a:t>Fourth level</a:t>
             </a:r>
           </a:p>
           <a:p>
             <a:pPr lvl="4"/>
             <a:r>
-              <a:rPr lang="en-US" smtClean="0"/>
+              <a:rPr lang="en-US"/>
               <a:t>Fifth level</a:t>
             </a:r>
-            <a:endParaRPr lang="en-US"/>
           </a:p>
         </p:txBody>
       </p:sp>
@@ -468,7 +480,7 @@
           <a:p>
             <a:fld id="{5BCAD085-E8A6-8845-BD4E-CB4CCA059FC4}" type="datetimeFigureOut">
               <a:rPr lang="en-US" smtClean="0"/>
-              <a:t>1/27/13</a:t>
+              <a:t>25-Jun-26</a:t>
             </a:fld>
             <a:endParaRPr lang="en-US"/>
           </a:p>
@@ -567,10 +579,9 @@
           <a:lstStyle/>
           <a:p>
             <a:r>
-              <a:rPr lang="en-US" smtClean="0"/>
+              <a:rPr lang="en-US"/>
               <a:t>Click to edit Master title style</a:t>
             </a:r>
-            <a:endParaRPr lang="en-US"/>
           </a:p>
         </p:txBody>
       </p:sp>
@@ -596,38 +607,37 @@
           <a:p>
             <a:pPr lvl="0"/>
             <a:r>
-              <a:rPr lang="en-US" smtClean="0"/>
+              <a:rPr lang="en-US"/>
               <a:t>Click to edit Master text styles</a:t>
             </a:r>
           </a:p>
           <a:p>
             <a:pPr lvl="1"/>
             <a:r>
-              <a:rPr lang="en-US" smtClean="0"/>
+              <a:rPr lang="en-US"/>
               <a:t>Second level</a:t>
             </a:r>
           </a:p>
           <a:p>
             <a:pPr lvl="2"/>
             <a:r>
-              <a:rPr lang="en-US" smtClean="0"/>
+              <a:rPr lang="en-US"/>
               <a:t>Third level</a:t>
             </a:r>
           </a:p>
           <a:p>
             <a:pPr lvl="3"/>
             <a:r>
-              <a:rPr lang="en-US" smtClean="0"/>
+              <a:rPr lang="en-US"/>
               <a:t>Fourth level</a:t>
             </a:r>
           </a:p>
           <a:p>
             <a:pPr lvl="4"/>
             <a:r>
-              <a:rPr lang="en-US" smtClean="0"/>
+              <a:rPr lang="en-US"/>
               <a:t>Fifth level</a:t>
             </a:r>
-            <a:endParaRPr lang="en-US"/>
           </a:p>
         </p:txBody>
       </p:sp>
@@ -648,7 +658,7 @@
           <a:p>
             <a:fld id="{5BCAD085-E8A6-8845-BD4E-CB4CCA059FC4}" type="datetimeFigureOut">
               <a:rPr lang="en-US" smtClean="0"/>
-              <a:t>1/27/13</a:t>
+              <a:t>25-Jun-26</a:t>
             </a:fld>
             <a:endParaRPr lang="en-US"/>
           </a:p>
@@ -742,10 +752,9 @@
           <a:lstStyle/>
           <a:p>
             <a:r>
-              <a:rPr lang="en-US" smtClean="0"/>
+              <a:rPr lang="en-US"/>
               <a:t>Click to edit Master title style</a:t>
             </a:r>
-            <a:endParaRPr lang="en-US"/>
           </a:p>
         </p:txBody>
       </p:sp>
@@ -766,38 +775,37 @@
           <a:p>
             <a:pPr lvl="0"/>
             <a:r>
-              <a:rPr lang="en-US" smtClean="0"/>
+              <a:rPr lang="en-US"/>
               <a:t>Click to edit Master text styles</a:t>
             </a:r>
           </a:p>
           <a:p>
             <a:pPr lvl="1"/>
             <a:r>
-              <a:rPr lang="en-US" smtClean="0"/>
+              <a:rPr lang="en-US"/>
               <a:t>Second level</a:t>
             </a:r>
           </a:p>
           <a:p>
             <a:pPr lvl="2"/>
             <a:r>
-              <a:rPr lang="en-US" smtClean="0"/>
+              <a:rPr lang="en-US"/>
               <a:t>Third level</a:t>
             </a:r>
           </a:p>
           <a:p>
             <a:pPr lvl="3"/>
             <a:r>
-              <a:rPr lang="en-US" smtClean="0"/>
+              <a:rPr lang="en-US"/>
               <a:t>Fourth level</a:t>
             </a:r>
           </a:p>
           <a:p>
             <a:pPr lvl="4"/>
             <a:r>
-              <a:rPr lang="en-US" smtClean="0"/>
+              <a:rPr lang="en-US"/>
               <a:t>Fifth level</a:t>
             </a:r>
-            <a:endParaRPr lang="en-US"/>
           </a:p>
         </p:txBody>
       </p:sp>
@@ -818,7 +826,7 @@
           <a:p>
             <a:fld id="{5BCAD085-E8A6-8845-BD4E-CB4CCA059FC4}" type="datetimeFigureOut">
               <a:rPr lang="en-US" smtClean="0"/>
-              <a:t>1/27/13</a:t>
+              <a:t>25-Jun-26</a:t>
             </a:fld>
             <a:endParaRPr lang="en-US"/>
           </a:p>
@@ -921,10 +929,9 @@
           </a:lstStyle>
           <a:p>
             <a:r>
-              <a:rPr lang="en-US" smtClean="0"/>
+              <a:rPr lang="en-US"/>
               <a:t>Click to edit Master title style</a:t>
             </a:r>
-            <a:endParaRPr lang="en-US"/>
           </a:p>
         </p:txBody>
       </p:sp>
@@ -1041,7 +1048,7 @@
           <a:p>
             <a:pPr lvl="0"/>
             <a:r>
-              <a:rPr lang="en-US" smtClean="0"/>
+              <a:rPr lang="en-US"/>
               <a:t>Click to edit Master text styles</a:t>
             </a:r>
           </a:p>
@@ -1064,7 +1071,7 @@
           <a:p>
             <a:fld id="{5BCAD085-E8A6-8845-BD4E-CB4CCA059FC4}" type="datetimeFigureOut">
               <a:rPr lang="en-US" smtClean="0"/>
-              <a:t>1/27/13</a:t>
+              <a:t>25-Jun-26</a:t>
             </a:fld>
             <a:endParaRPr lang="en-US"/>
           </a:p>
@@ -1158,10 +1165,9 @@
           <a:lstStyle/>
           <a:p>
             <a:r>
-              <a:rPr lang="en-US" smtClean="0"/>
+              <a:rPr lang="en-US"/>
               <a:t>Click to edit Master title style</a:t>
             </a:r>
-            <a:endParaRPr lang="en-US"/>
           </a:p>
         </p:txBody>
       </p:sp>
@@ -1215,38 +1221,37 @@
           <a:p>
             <a:pPr lvl="0"/>
             <a:r>
-              <a:rPr lang="en-US" smtClean="0"/>
+              <a:rPr lang="en-US"/>
               <a:t>Click to edit Master text styles</a:t>
             </a:r>
           </a:p>
           <a:p>
             <a:pPr lvl="1"/>
             <a:r>
-              <a:rPr lang="en-US" smtClean="0"/>
+              <a:rPr lang="en-US"/>
               <a:t>Second level</a:t>
             </a:r>
           </a:p>
           <a:p>
             <a:pPr lvl="2"/>
             <a:r>
-              <a:rPr lang="en-US" smtClean="0"/>
+              <a:rPr lang="en-US"/>
               <a:t>Third level</a:t>
             </a:r>
           </a:p>
           <a:p>
             <a:pPr lvl="3"/>
             <a:r>
-              <a:rPr lang="en-US" smtClean="0"/>
+              <a:rPr lang="en-US"/>
               <a:t>Fourth level</a:t>
             </a:r>
           </a:p>
           <a:p>
             <a:pPr lvl="4"/>
             <a:r>
-              <a:rPr lang="en-US" smtClean="0"/>
+              <a:rPr lang="en-US"/>
               <a:t>Fifth level</a:t>
             </a:r>
-            <a:endParaRPr lang="en-US"/>
           </a:p>
         </p:txBody>
       </p:sp>
@@ -1300,38 +1305,37 @@
           <a:p>
             <a:pPr lvl="0"/>
             <a:r>
-              <a:rPr lang="en-US" smtClean="0"/>
+              <a:rPr lang="en-US"/>
               <a:t>Click to edit Master text styles</a:t>
             </a:r>
           </a:p>
           <a:p>
             <a:pPr lvl="1"/>
             <a:r>
-              <a:rPr lang="en-US" smtClean="0"/>
+              <a:rPr lang="en-US"/>
               <a:t>Second level</a:t>
             </a:r>
           </a:p>
           <a:p>
             <a:pPr lvl="2"/>
             <a:r>
-              <a:rPr lang="en-US" smtClean="0"/>
+              <a:rPr lang="en-US"/>
               <a:t>Third level</a:t>
             </a:r>
           </a:p>
           <a:p>
             <a:pPr lvl="3"/>
             <a:r>
-              <a:rPr lang="en-US" smtClean="0"/>
+              <a:rPr lang="en-US"/>
               <a:t>Fourth level</a:t>
             </a:r>
           </a:p>
           <a:p>
             <a:pPr lvl="4"/>
             <a:r>
-              <a:rPr lang="en-US" smtClean="0"/>
+              <a:rPr lang="en-US"/>
               <a:t>Fifth level</a:t>
             </a:r>
-            <a:endParaRPr lang="en-US"/>
           </a:p>
         </p:txBody>
       </p:sp>
@@ -1352,7 +1356,7 @@
           <a:p>
             <a:fld id="{5BCAD085-E8A6-8845-BD4E-CB4CCA059FC4}" type="datetimeFigureOut">
               <a:rPr lang="en-US" smtClean="0"/>
-              <a:t>1/27/13</a:t>
+              <a:t>25-Jun-26</a:t>
             </a:fld>
             <a:endParaRPr lang="en-US"/>
           </a:p>
@@ -1450,10 +1454,9 @@
           </a:lstStyle>
           <a:p>
             <a:r>
-              <a:rPr lang="en-US" smtClean="0"/>
+              <a:rPr lang="en-US"/>
               <a:t>Click to edit Master title style</a:t>
             </a:r>
-            <a:endParaRPr lang="en-US"/>
           </a:p>
         </p:txBody>
       </p:sp>
@@ -1516,7 +1519,7 @@
           <a:p>
             <a:pPr lvl="0"/>
             <a:r>
-              <a:rPr lang="en-US" smtClean="0"/>
+              <a:rPr lang="en-US"/>
               <a:t>Click to edit Master text styles</a:t>
             </a:r>
           </a:p>
@@ -1572,38 +1575,37 @@
           <a:p>
             <a:pPr lvl="0"/>
             <a:r>
-              <a:rPr lang="en-US" smtClean="0"/>
+              <a:rPr lang="en-US"/>
               <a:t>Click to edit Master text styles</a:t>
             </a:r>
           </a:p>
           <a:p>
             <a:pPr lvl="1"/>
             <a:r>
-              <a:rPr lang="en-US" smtClean="0"/>
+              <a:rPr lang="en-US"/>
               <a:t>Second level</a:t>
             </a:r>
           </a:p>
           <a:p>
             <a:pPr lvl="2"/>
             <a:r>
-              <a:rPr lang="en-US" smtClean="0"/>
+              <a:rPr lang="en-US"/>
               <a:t>Third level</a:t>
             </a:r>
           </a:p>
           <a:p>
             <a:pPr lvl="3"/>
             <a:r>
-              <a:rPr lang="en-US" smtClean="0"/>
+              <a:rPr lang="en-US"/>
               <a:t>Fourth level</a:t>
             </a:r>
           </a:p>
           <a:p>
             <a:pPr lvl="4"/>
             <a:r>
-              <a:rPr lang="en-US" smtClean="0"/>
+              <a:rPr lang="en-US"/>
               <a:t>Fifth level</a:t>
             </a:r>
-            <a:endParaRPr lang="en-US"/>
           </a:p>
         </p:txBody>
       </p:sp>
@@ -1666,7 +1668,7 @@
           <a:p>
             <a:pPr lvl="0"/>
             <a:r>
-              <a:rPr lang="en-US" smtClean="0"/>
+              <a:rPr lang="en-US"/>
               <a:t>Click to edit Master text styles</a:t>
             </a:r>
           </a:p>
@@ -1722,38 +1724,37 @@
           <a:p>
             <a:pPr lvl="0"/>
             <a:r>
-              <a:rPr lang="en-US" smtClean="0"/>
+              <a:rPr lang="en-US"/>
               <a:t>Click to edit Master text styles</a:t>
             </a:r>
           </a:p>
           <a:p>
             <a:pPr lvl="1"/>
             <a:r>
-              <a:rPr lang="en-US" smtClean="0"/>
+              <a:rPr lang="en-US"/>
               <a:t>Second level</a:t>
             </a:r>
           </a:p>
           <a:p>
             <a:pPr lvl="2"/>
             <a:r>
-              <a:rPr lang="en-US" smtClean="0"/>
+              <a:rPr lang="en-US"/>
               <a:t>Third level</a:t>
             </a:r>
           </a:p>
           <a:p>
             <a:pPr lvl="3"/>
             <a:r>
-              <a:rPr lang="en-US" smtClean="0"/>
+              <a:rPr lang="en-US"/>
               <a:t>Fourth level</a:t>
             </a:r>
           </a:p>
           <a:p>
             <a:pPr lvl="4"/>
             <a:r>
-              <a:rPr lang="en-US" smtClean="0"/>
+              <a:rPr lang="en-US"/>
               <a:t>Fifth level</a:t>
             </a:r>
-            <a:endParaRPr lang="en-US"/>
           </a:p>
         </p:txBody>
       </p:sp>
@@ -1774,7 +1775,7 @@
           <a:p>
             <a:fld id="{5BCAD085-E8A6-8845-BD4E-CB4CCA059FC4}" type="datetimeFigureOut">
               <a:rPr lang="en-US" smtClean="0"/>
-              <a:t>1/27/13</a:t>
+              <a:t>25-Jun-26</a:t>
             </a:fld>
             <a:endParaRPr lang="en-US"/>
           </a:p>
@@ -1868,10 +1869,9 @@
           <a:lstStyle/>
           <a:p>
             <a:r>
-              <a:rPr lang="en-US" smtClean="0"/>
+              <a:rPr lang="en-US"/>
               <a:t>Click to edit Master title style</a:t>
             </a:r>
-            <a:endParaRPr lang="en-US"/>
           </a:p>
         </p:txBody>
       </p:sp>
@@ -1892,7 +1892,7 @@
           <a:p>
             <a:fld id="{5BCAD085-E8A6-8845-BD4E-CB4CCA059FC4}" type="datetimeFigureOut">
               <a:rPr lang="en-US" smtClean="0"/>
-              <a:t>1/27/13</a:t>
+              <a:t>25-Jun-26</a:t>
             </a:fld>
             <a:endParaRPr lang="en-US"/>
           </a:p>
@@ -1987,7 +1987,7 @@
           <a:p>
             <a:fld id="{5BCAD085-E8A6-8845-BD4E-CB4CCA059FC4}" type="datetimeFigureOut">
               <a:rPr lang="en-US" smtClean="0"/>
-              <a:t>1/27/13</a:t>
+              <a:t>25-Jun-26</a:t>
             </a:fld>
             <a:endParaRPr lang="en-US"/>
           </a:p>
@@ -2090,10 +2090,9 @@
           </a:lstStyle>
           <a:p>
             <a:r>
-              <a:rPr lang="en-US" smtClean="0"/>
+              <a:rPr lang="en-US"/>
               <a:t>Click to edit Master title style</a:t>
             </a:r>
-            <a:endParaRPr lang="en-US"/>
           </a:p>
         </p:txBody>
       </p:sp>
@@ -2147,38 +2146,37 @@
           <a:p>
             <a:pPr lvl="0"/>
             <a:r>
-              <a:rPr lang="en-US" smtClean="0"/>
+              <a:rPr lang="en-US"/>
               <a:t>Click to edit Master text styles</a:t>
             </a:r>
           </a:p>
           <a:p>
             <a:pPr lvl="1"/>
             <a:r>
-              <a:rPr lang="en-US" smtClean="0"/>
+              <a:rPr lang="en-US"/>
               <a:t>Second level</a:t>
             </a:r>
           </a:p>
           <a:p>
             <a:pPr lvl="2"/>
             <a:r>
-              <a:rPr lang="en-US" smtClean="0"/>
+              <a:rPr lang="en-US"/>
               <a:t>Third level</a:t>
             </a:r>
           </a:p>
           <a:p>
             <a:pPr lvl="3"/>
             <a:r>
-              <a:rPr lang="en-US" smtClean="0"/>
+              <a:rPr lang="en-US"/>
               <a:t>Fourth level</a:t>
             </a:r>
           </a:p>
           <a:p>
             <a:pPr lvl="4"/>
             <a:r>
-              <a:rPr lang="en-US" smtClean="0"/>
+              <a:rPr lang="en-US"/>
               <a:t>Fifth level</a:t>
             </a:r>
-            <a:endParaRPr lang="en-US"/>
           </a:p>
         </p:txBody>
       </p:sp>
@@ -2241,7 +2239,7 @@
           <a:p>
             <a:pPr lvl="0"/>
             <a:r>
-              <a:rPr lang="en-US" smtClean="0"/>
+              <a:rPr lang="en-US"/>
               <a:t>Click to edit Master text styles</a:t>
             </a:r>
           </a:p>
@@ -2264,7 +2262,7 @@
           <a:p>
             <a:fld id="{5BCAD085-E8A6-8845-BD4E-CB4CCA059FC4}" type="datetimeFigureOut">
               <a:rPr lang="en-US" smtClean="0"/>
-              <a:t>1/27/13</a:t>
+              <a:t>25-Jun-26</a:t>
             </a:fld>
             <a:endParaRPr lang="en-US"/>
           </a:p>
@@ -2367,10 +2365,9 @@
           </a:lstStyle>
           <a:p>
             <a:r>
-              <a:rPr lang="en-US" smtClean="0"/>
+              <a:rPr lang="en-US"/>
               <a:t>Click to edit Master title style</a:t>
             </a:r>
-            <a:endParaRPr lang="en-US"/>
           </a:p>
         </p:txBody>
       </p:sp>
@@ -2494,7 +2491,7 @@
           <a:p>
             <a:pPr lvl="0"/>
             <a:r>
-              <a:rPr lang="en-US" smtClean="0"/>
+              <a:rPr lang="en-US"/>
               <a:t>Click to edit Master text styles</a:t>
             </a:r>
           </a:p>
@@ -2517,7 +2514,7 @@
           <a:p>
             <a:fld id="{5BCAD085-E8A6-8845-BD4E-CB4CCA059FC4}" type="datetimeFigureOut">
               <a:rPr lang="en-US" smtClean="0"/>
-              <a:t>1/27/13</a:t>
+              <a:t>25-Jun-26</a:t>
             </a:fld>
             <a:endParaRPr lang="en-US"/>
           </a:p>
@@ -2626,10 +2623,9 @@
           <a:lstStyle/>
           <a:p>
             <a:r>
-              <a:rPr lang="en-US" smtClean="0"/>
+              <a:rPr lang="en-US"/>
               <a:t>Click to edit Master title style</a:t>
             </a:r>
-            <a:endParaRPr lang="en-US"/>
           </a:p>
         </p:txBody>
       </p:sp>
@@ -2660,38 +2656,37 @@
           <a:p>
             <a:pPr lvl="0"/>
             <a:r>
-              <a:rPr lang="en-US" smtClean="0"/>
+              <a:rPr lang="en-US"/>
               <a:t>Click to edit Master text styles</a:t>
             </a:r>
           </a:p>
           <a:p>
             <a:pPr lvl="1"/>
             <a:r>
-              <a:rPr lang="en-US" smtClean="0"/>
+              <a:rPr lang="en-US"/>
               <a:t>Second level</a:t>
             </a:r>
           </a:p>
           <a:p>
             <a:pPr lvl="2"/>
             <a:r>
-              <a:rPr lang="en-US" smtClean="0"/>
+              <a:rPr lang="en-US"/>
               <a:t>Third level</a:t>
             </a:r>
           </a:p>
           <a:p>
             <a:pPr lvl="3"/>
             <a:r>
-              <a:rPr lang="en-US" smtClean="0"/>
+              <a:rPr lang="en-US"/>
               <a:t>Fourth level</a:t>
             </a:r>
           </a:p>
           <a:p>
             <a:pPr lvl="4"/>
             <a:r>
-              <a:rPr lang="en-US" smtClean="0"/>
+              <a:rPr lang="en-US"/>
               <a:t>Fifth level</a:t>
             </a:r>
-            <a:endParaRPr lang="en-US"/>
           </a:p>
         </p:txBody>
       </p:sp>
@@ -2730,7 +2725,7 @@
           <a:p>
             <a:fld id="{5BCAD085-E8A6-8845-BD4E-CB4CCA059FC4}" type="datetimeFigureOut">
               <a:rPr lang="en-US" smtClean="0"/>
-              <a:t>1/27/13</a:t>
+              <a:t>25-Jun-26</a:t>
             </a:fld>
             <a:endParaRPr lang="en-US"/>
           </a:p>
@@ -3089,7 +3084,7 @@
 </file>
 
 <file path=ppt/slides/slide1.xml><?xml version="1.0" encoding="utf-8"?>
-<p:sld xmlns:a="http://schemas.openxmlformats.org/drawingml/2006/main" xmlns:p="http://schemas.openxmlformats.org/presentationml/2006/main" xmlns:r="http://schemas.openxmlformats.org/officeDocument/2006/relationships">
+<p:sld xmlns:a="http://schemas.openxmlformats.org/drawingml/2006/main" xmlns:r="http://schemas.openxmlformats.org/officeDocument/2006/relationships" xmlns:p="http://schemas.openxmlformats.org/presentationml/2006/main">
   <p:cSld>
     <p:bg>
       <p:bgPr>
@@ -3105,7 +3100,14 @@
         <p:cNvGrpSpPr/>
         <p:nvPr/>
       </p:nvGrpSpPr>
-      <p:grpSpPr/>
+      <p:grpSpPr>
+        <a:xfrm>
+          <a:off x="0" y="0"/>
+          <a:ext cx="0" cy="0"/>
+          <a:chOff x="0" y="0"/>
+          <a:chExt cx="0" cy="0"/>
+        </a:xfrm>
+      </p:grpSpPr>
       <p:sp>
         <p:nvSpPr>
           <p:cNvPr id="2" name="Rectangle 1"/>
@@ -3146,6 +3148,7 @@
           <a:lstStyle/>
           <a:p>
             <a:pPr algn="ctr"/>
+            <a:endParaRPr/>
           </a:p>
         </p:txBody>
       </p:sp>
@@ -3189,6 +3192,7 @@
           <a:lstStyle/>
           <a:p>
             <a:pPr algn="ctr"/>
+            <a:endParaRPr/>
           </a:p>
         </p:txBody>
       </p:sp>
@@ -3232,6 +3236,7 @@
           <a:lstStyle/>
           <a:p>
             <a:pPr algn="ctr"/>
+            <a:endParaRPr/>
           </a:p>
         </p:txBody>
       </p:sp>
@@ -3343,6 +3348,7 @@
           <a:lstStyle/>
           <a:p>
             <a:pPr algn="ctr"/>
+            <a:endParaRPr/>
           </a:p>
         </p:txBody>
       </p:sp>
@@ -3355,7 +3361,7 @@
         <p:spPr>
           <a:xfrm>
             <a:off x="457200" y="2788920"/>
-            <a:ext cx="11247120" cy="365760"/>
+            <a:ext cx="11247120" cy="338554"/>
           </a:xfrm>
           <a:prstGeom prst="rect">
             <a:avLst/>
@@ -3370,13 +3376,26 @@
           <a:p>
             <a:pPr algn="ctr"/>
             <a:r>
-              <a:rPr sz="1600" b="0" i="0">
+              <a:rPr sz="1600" b="0" i="0" dirty="0">
                 <a:solidFill>
                   <a:srgbClr val="CFE4F6"/>
                 </a:solidFill>
               </a:rPr>
               <a:t>Salman Zaman  ·  Muhammad Usama Alam</a:t>
             </a:r>
+            <a:r>
+              <a:rPr lang="en-US" sz="1600" dirty="0">
+                <a:solidFill>
+                  <a:srgbClr val="CFE4F6"/>
+                </a:solidFill>
+              </a:rPr>
+              <a:t> ·  Muhammad Zafar Khan</a:t>
+            </a:r>
+            <a:endParaRPr sz="1600" b="0" i="0" dirty="0">
+              <a:solidFill>
+                <a:srgbClr val="CFE4F6"/>
+              </a:solidFill>
+            </a:endParaRPr>
           </a:p>
         </p:txBody>
       </p:sp>
@@ -3556,6 +3575,7 @@
           <a:lstStyle/>
           <a:p>
             <a:pPr algn="ctr"/>
+            <a:endParaRPr/>
           </a:p>
         </p:txBody>
       </p:sp>
@@ -3599,6 +3619,7 @@
           <a:lstStyle/>
           <a:p>
             <a:pPr algn="ctr"/>
+            <a:endParaRPr/>
           </a:p>
         </p:txBody>
       </p:sp>
@@ -3679,7 +3700,7 @@
 </file>
 
 <file path=ppt/slides/slide10.xml><?xml version="1.0" encoding="utf-8"?>
-<p:sld xmlns:a="http://schemas.openxmlformats.org/drawingml/2006/main" xmlns:p="http://schemas.openxmlformats.org/presentationml/2006/main" xmlns:r="http://schemas.openxmlformats.org/officeDocument/2006/relationships">
+<p:sld xmlns:a="http://schemas.openxmlformats.org/drawingml/2006/main" xmlns:r="http://schemas.openxmlformats.org/officeDocument/2006/relationships" xmlns:p="http://schemas.openxmlformats.org/presentationml/2006/main">
   <p:cSld>
     <p:bg>
       <p:bgPr>
@@ -3695,7 +3716,14 @@
         <p:cNvGrpSpPr/>
         <p:nvPr/>
       </p:nvGrpSpPr>
-      <p:grpSpPr/>
+      <p:grpSpPr>
+        <a:xfrm>
+          <a:off x="0" y="0"/>
+          <a:ext cx="0" cy="0"/>
+          <a:chOff x="0" y="0"/>
+          <a:chExt cx="0" cy="0"/>
+        </a:xfrm>
+      </p:grpSpPr>
       <p:sp>
         <p:nvSpPr>
           <p:cNvPr id="2" name="Rectangle 1"/>
@@ -3736,6 +3764,7 @@
           <a:lstStyle/>
           <a:p>
             <a:pPr algn="ctr"/>
+            <a:endParaRPr/>
           </a:p>
         </p:txBody>
       </p:sp>
@@ -3779,6 +3808,7 @@
           <a:lstStyle/>
           <a:p>
             <a:pPr algn="ctr"/>
+            <a:endParaRPr/>
           </a:p>
         </p:txBody>
       </p:sp>
@@ -3822,6 +3852,7 @@
           <a:lstStyle/>
           <a:p>
             <a:pPr algn="ctr"/>
+            <a:endParaRPr/>
           </a:p>
         </p:txBody>
       </p:sp>
@@ -3933,6 +3964,7 @@
           <a:lstStyle/>
           <a:p>
             <a:pPr algn="ctr"/>
+            <a:endParaRPr/>
           </a:p>
         </p:txBody>
       </p:sp>
@@ -3976,6 +4008,7 @@
           <a:lstStyle/>
           <a:p>
             <a:pPr algn="ctr"/>
+            <a:endParaRPr/>
           </a:p>
         </p:txBody>
       </p:sp>
@@ -4111,6 +4144,7 @@
           <a:lstStyle/>
           <a:p>
             <a:pPr algn="ctr"/>
+            <a:endParaRPr/>
           </a:p>
         </p:txBody>
       </p:sp>
@@ -4154,6 +4188,7 @@
           <a:lstStyle/>
           <a:p>
             <a:pPr algn="ctr"/>
+            <a:endParaRPr/>
           </a:p>
         </p:txBody>
       </p:sp>
@@ -4329,6 +4364,7 @@
           <a:lstStyle/>
           <a:p>
             <a:pPr algn="ctr"/>
+            <a:endParaRPr/>
           </a:p>
         </p:txBody>
       </p:sp>
@@ -4372,6 +4408,7 @@
           <a:lstStyle/>
           <a:p>
             <a:pPr algn="ctr"/>
+            <a:endParaRPr/>
           </a:p>
         </p:txBody>
       </p:sp>
@@ -4547,6 +4584,7 @@
           <a:lstStyle/>
           <a:p>
             <a:pPr algn="ctr"/>
+            <a:endParaRPr/>
           </a:p>
         </p:txBody>
       </p:sp>
@@ -4590,6 +4628,7 @@
           <a:lstStyle/>
           <a:p>
             <a:pPr algn="ctr"/>
+            <a:endParaRPr/>
           </a:p>
         </p:txBody>
       </p:sp>
@@ -4670,7 +4709,7 @@
 </file>
 
 <file path=ppt/slides/slide11.xml><?xml version="1.0" encoding="utf-8"?>
-<p:sld xmlns:a="http://schemas.openxmlformats.org/drawingml/2006/main" xmlns:p="http://schemas.openxmlformats.org/presentationml/2006/main" xmlns:r="http://schemas.openxmlformats.org/officeDocument/2006/relationships">
+<p:sld xmlns:a="http://schemas.openxmlformats.org/drawingml/2006/main" xmlns:r="http://schemas.openxmlformats.org/officeDocument/2006/relationships" xmlns:p="http://schemas.openxmlformats.org/presentationml/2006/main">
   <p:cSld>
     <p:bg>
       <p:bgPr>
@@ -4686,7 +4725,14 @@
         <p:cNvGrpSpPr/>
         <p:nvPr/>
       </p:nvGrpSpPr>
-      <p:grpSpPr/>
+      <p:grpSpPr>
+        <a:xfrm>
+          <a:off x="0" y="0"/>
+          <a:ext cx="0" cy="0"/>
+          <a:chOff x="0" y="0"/>
+          <a:chExt cx="0" cy="0"/>
+        </a:xfrm>
+      </p:grpSpPr>
       <p:sp>
         <p:nvSpPr>
           <p:cNvPr id="2" name="Rectangle 1"/>
@@ -4727,6 +4773,7 @@
           <a:lstStyle/>
           <a:p>
             <a:pPr algn="ctr"/>
+            <a:endParaRPr/>
           </a:p>
         </p:txBody>
       </p:sp>
@@ -4770,6 +4817,7 @@
           <a:lstStyle/>
           <a:p>
             <a:pPr algn="ctr"/>
+            <a:endParaRPr/>
           </a:p>
         </p:txBody>
       </p:sp>
@@ -4813,6 +4861,7 @@
           <a:lstStyle/>
           <a:p>
             <a:pPr algn="ctr"/>
+            <a:endParaRPr/>
           </a:p>
         </p:txBody>
       </p:sp>
@@ -4924,6 +4973,7 @@
           <a:lstStyle/>
           <a:p>
             <a:pPr algn="ctr"/>
+            <a:endParaRPr/>
           </a:p>
         </p:txBody>
       </p:sp>
@@ -4967,6 +5017,7 @@
           <a:lstStyle/>
           <a:p>
             <a:pPr algn="ctr"/>
+            <a:endParaRPr/>
           </a:p>
         </p:txBody>
       </p:sp>
@@ -5078,6 +5129,7 @@
           <a:lstStyle/>
           <a:p>
             <a:pPr algn="ctr"/>
+            <a:endParaRPr/>
           </a:p>
         </p:txBody>
       </p:sp>
@@ -5121,6 +5173,7 @@
           <a:lstStyle/>
           <a:p>
             <a:pPr algn="ctr"/>
+            <a:endParaRPr/>
           </a:p>
         </p:txBody>
       </p:sp>
@@ -5356,6 +5409,7 @@
           <a:lstStyle/>
           <a:p>
             <a:pPr algn="ctr"/>
+            <a:endParaRPr/>
           </a:p>
         </p:txBody>
       </p:sp>
@@ -5399,6 +5453,7 @@
           <a:lstStyle/>
           <a:p>
             <a:pPr algn="ctr"/>
+            <a:endParaRPr/>
           </a:p>
         </p:txBody>
       </p:sp>
@@ -5574,6 +5629,7 @@
           <a:lstStyle/>
           <a:p>
             <a:pPr algn="ctr"/>
+            <a:endParaRPr/>
           </a:p>
         </p:txBody>
       </p:sp>
@@ -5617,6 +5673,7 @@
           <a:lstStyle/>
           <a:p>
             <a:pPr algn="ctr"/>
+            <a:endParaRPr/>
           </a:p>
         </p:txBody>
       </p:sp>
@@ -5776,7 +5833,7 @@
 </file>
 
 <file path=ppt/slides/slide2.xml><?xml version="1.0" encoding="utf-8"?>
-<p:sld xmlns:a="http://schemas.openxmlformats.org/drawingml/2006/main" xmlns:p="http://schemas.openxmlformats.org/presentationml/2006/main" xmlns:r="http://schemas.openxmlformats.org/officeDocument/2006/relationships">
+<p:sld xmlns:a="http://schemas.openxmlformats.org/drawingml/2006/main" xmlns:r="http://schemas.openxmlformats.org/officeDocument/2006/relationships" xmlns:p="http://schemas.openxmlformats.org/presentationml/2006/main">
   <p:cSld>
     <p:bg>
       <p:bgPr>
@@ -5792,7 +5849,14 @@
         <p:cNvGrpSpPr/>
         <p:nvPr/>
       </p:nvGrpSpPr>
-      <p:grpSpPr/>
+      <p:grpSpPr>
+        <a:xfrm>
+          <a:off x="0" y="0"/>
+          <a:ext cx="0" cy="0"/>
+          <a:chOff x="0" y="0"/>
+          <a:chExt cx="0" cy="0"/>
+        </a:xfrm>
+      </p:grpSpPr>
       <p:sp>
         <p:nvSpPr>
           <p:cNvPr id="2" name="Rectangle 1"/>
@@ -5833,6 +5897,7 @@
           <a:lstStyle/>
           <a:p>
             <a:pPr algn="ctr"/>
+            <a:endParaRPr/>
           </a:p>
         </p:txBody>
       </p:sp>
@@ -5876,6 +5941,7 @@
           <a:lstStyle/>
           <a:p>
             <a:pPr algn="ctr"/>
+            <a:endParaRPr/>
           </a:p>
         </p:txBody>
       </p:sp>
@@ -5919,6 +5985,7 @@
           <a:lstStyle/>
           <a:p>
             <a:pPr algn="ctr"/>
+            <a:endParaRPr/>
           </a:p>
         </p:txBody>
       </p:sp>
@@ -6030,6 +6097,7 @@
           <a:lstStyle/>
           <a:p>
             <a:pPr algn="ctr"/>
+            <a:endParaRPr/>
           </a:p>
         </p:txBody>
       </p:sp>
@@ -6073,6 +6141,7 @@
           <a:lstStyle/>
           <a:p>
             <a:pPr algn="ctr"/>
+            <a:endParaRPr/>
           </a:p>
         </p:txBody>
       </p:sp>
@@ -6184,6 +6253,7 @@
           <a:lstStyle/>
           <a:p>
             <a:pPr algn="ctr"/>
+            <a:endParaRPr/>
           </a:p>
         </p:txBody>
       </p:sp>
@@ -6227,6 +6297,7 @@
           <a:lstStyle/>
           <a:p>
             <a:pPr algn="ctr"/>
+            <a:endParaRPr/>
           </a:p>
         </p:txBody>
       </p:sp>
@@ -6341,6 +6412,7 @@
                 </a:solidFill>
               </a:defRPr>
             </a:pPr>
+            <a:endParaRPr/>
           </a:p>
           <a:p>
             <a:pPr>
@@ -6613,7 +6685,7 @@
 </file>
 
 <file path=ppt/slides/slide3.xml><?xml version="1.0" encoding="utf-8"?>
-<p:sld xmlns:a="http://schemas.openxmlformats.org/drawingml/2006/main" xmlns:p="http://schemas.openxmlformats.org/presentationml/2006/main" xmlns:r="http://schemas.openxmlformats.org/officeDocument/2006/relationships">
+<p:sld xmlns:a="http://schemas.openxmlformats.org/drawingml/2006/main" xmlns:r="http://schemas.openxmlformats.org/officeDocument/2006/relationships" xmlns:p="http://schemas.openxmlformats.org/presentationml/2006/main">
   <p:cSld>
     <p:bg>
       <p:bgPr>
@@ -6629,7 +6701,14 @@
         <p:cNvGrpSpPr/>
         <p:nvPr/>
       </p:nvGrpSpPr>
-      <p:grpSpPr/>
+      <p:grpSpPr>
+        <a:xfrm>
+          <a:off x="0" y="0"/>
+          <a:ext cx="0" cy="0"/>
+          <a:chOff x="0" y="0"/>
+          <a:chExt cx="0" cy="0"/>
+        </a:xfrm>
+      </p:grpSpPr>
       <p:sp>
         <p:nvSpPr>
           <p:cNvPr id="2" name="Rectangle 1"/>
@@ -6670,6 +6749,7 @@
           <a:lstStyle/>
           <a:p>
             <a:pPr algn="ctr"/>
+            <a:endParaRPr/>
           </a:p>
         </p:txBody>
       </p:sp>
@@ -6713,6 +6793,7 @@
           <a:lstStyle/>
           <a:p>
             <a:pPr algn="ctr"/>
+            <a:endParaRPr/>
           </a:p>
         </p:txBody>
       </p:sp>
@@ -6756,6 +6837,7 @@
           <a:lstStyle/>
           <a:p>
             <a:pPr algn="ctr"/>
+            <a:endParaRPr/>
           </a:p>
         </p:txBody>
       </p:sp>
@@ -6867,6 +6949,7 @@
           <a:lstStyle/>
           <a:p>
             <a:pPr algn="ctr"/>
+            <a:endParaRPr/>
           </a:p>
         </p:txBody>
       </p:sp>
@@ -6910,6 +6993,7 @@
           <a:lstStyle/>
           <a:p>
             <a:pPr algn="ctr"/>
+            <a:endParaRPr/>
           </a:p>
         </p:txBody>
       </p:sp>
@@ -7045,6 +7129,7 @@
           <a:lstStyle/>
           <a:p>
             <a:pPr algn="ctr"/>
+            <a:endParaRPr/>
           </a:p>
         </p:txBody>
       </p:sp>
@@ -7088,6 +7173,7 @@
           <a:lstStyle/>
           <a:p>
             <a:pPr algn="ctr"/>
+            <a:endParaRPr/>
           </a:p>
         </p:txBody>
       </p:sp>
@@ -7263,6 +7349,7 @@
           <a:lstStyle/>
           <a:p>
             <a:pPr algn="ctr"/>
+            <a:endParaRPr/>
           </a:p>
         </p:txBody>
       </p:sp>
@@ -7306,6 +7393,7 @@
           <a:lstStyle/>
           <a:p>
             <a:pPr algn="ctr"/>
+            <a:endParaRPr/>
           </a:p>
         </p:txBody>
       </p:sp>
@@ -7450,7 +7538,7 @@
 </file>
 
 <file path=ppt/slides/slide4.xml><?xml version="1.0" encoding="utf-8"?>
-<p:sld xmlns:a="http://schemas.openxmlformats.org/drawingml/2006/main" xmlns:p="http://schemas.openxmlformats.org/presentationml/2006/main" xmlns:r="http://schemas.openxmlformats.org/officeDocument/2006/relationships">
+<p:sld xmlns:a="http://schemas.openxmlformats.org/drawingml/2006/main" xmlns:r="http://schemas.openxmlformats.org/officeDocument/2006/relationships" xmlns:p="http://schemas.openxmlformats.org/presentationml/2006/main">
   <p:cSld>
     <p:bg>
       <p:bgPr>
@@ -7466,7 +7554,14 @@
         <p:cNvGrpSpPr/>
         <p:nvPr/>
       </p:nvGrpSpPr>
-      <p:grpSpPr/>
+      <p:grpSpPr>
+        <a:xfrm>
+          <a:off x="0" y="0"/>
+          <a:ext cx="0" cy="0"/>
+          <a:chOff x="0" y="0"/>
+          <a:chExt cx="0" cy="0"/>
+        </a:xfrm>
+      </p:grpSpPr>
       <p:sp>
         <p:nvSpPr>
           <p:cNvPr id="2" name="Rectangle 1"/>
@@ -7507,6 +7602,7 @@
           <a:lstStyle/>
           <a:p>
             <a:pPr algn="ctr"/>
+            <a:endParaRPr/>
           </a:p>
         </p:txBody>
       </p:sp>
@@ -7550,6 +7646,7 @@
           <a:lstStyle/>
           <a:p>
             <a:pPr algn="ctr"/>
+            <a:endParaRPr/>
           </a:p>
         </p:txBody>
       </p:sp>
@@ -7593,6 +7690,7 @@
           <a:lstStyle/>
           <a:p>
             <a:pPr algn="ctr"/>
+            <a:endParaRPr/>
           </a:p>
         </p:txBody>
       </p:sp>
@@ -7704,6 +7802,7 @@
           <a:lstStyle/>
           <a:p>
             <a:pPr algn="ctr"/>
+            <a:endParaRPr/>
           </a:p>
         </p:txBody>
       </p:sp>
@@ -7747,6 +7846,7 @@
           <a:lstStyle/>
           <a:p>
             <a:pPr algn="ctr"/>
+            <a:endParaRPr/>
           </a:p>
         </p:txBody>
       </p:sp>
@@ -7882,6 +7982,7 @@
           <a:lstStyle/>
           <a:p>
             <a:pPr algn="ctr"/>
+            <a:endParaRPr/>
           </a:p>
         </p:txBody>
       </p:sp>
@@ -7925,6 +8026,7 @@
           <a:lstStyle/>
           <a:p>
             <a:pPr algn="ctr"/>
+            <a:endParaRPr/>
           </a:p>
         </p:txBody>
       </p:sp>
@@ -8037,6 +8139,7 @@
           <a:lstStyle/>
           <a:p>
             <a:pPr algn="ctr"/>
+            <a:endParaRPr/>
           </a:p>
         </p:txBody>
       </p:sp>
@@ -8080,6 +8183,7 @@
           <a:lstStyle/>
           <a:p>
             <a:pPr algn="ctr"/>
+            <a:endParaRPr/>
           </a:p>
         </p:txBody>
       </p:sp>
@@ -8192,6 +8296,7 @@
           <a:lstStyle/>
           <a:p>
             <a:pPr algn="ctr"/>
+            <a:endParaRPr/>
           </a:p>
         </p:txBody>
       </p:sp>
@@ -8235,6 +8340,7 @@
           <a:lstStyle/>
           <a:p>
             <a:pPr algn="ctr"/>
+            <a:endParaRPr/>
           </a:p>
         </p:txBody>
       </p:sp>
@@ -8347,6 +8453,7 @@
           <a:lstStyle/>
           <a:p>
             <a:pPr algn="ctr"/>
+            <a:endParaRPr/>
           </a:p>
         </p:txBody>
       </p:sp>
@@ -8390,6 +8497,7 @@
           <a:lstStyle/>
           <a:p>
             <a:pPr algn="ctr"/>
+            <a:endParaRPr/>
           </a:p>
         </p:txBody>
       </p:sp>
@@ -8471,7 +8579,7 @@
 </file>
 
 <file path=ppt/slides/slide5.xml><?xml version="1.0" encoding="utf-8"?>
-<p:sld xmlns:a="http://schemas.openxmlformats.org/drawingml/2006/main" xmlns:p="http://schemas.openxmlformats.org/presentationml/2006/main" xmlns:r="http://schemas.openxmlformats.org/officeDocument/2006/relationships">
+<p:sld xmlns:a="http://schemas.openxmlformats.org/drawingml/2006/main" xmlns:r="http://schemas.openxmlformats.org/officeDocument/2006/relationships" xmlns:p="http://schemas.openxmlformats.org/presentationml/2006/main">
   <p:cSld>
     <p:bg>
       <p:bgPr>
@@ -8487,7 +8595,14 @@
         <p:cNvGrpSpPr/>
         <p:nvPr/>
       </p:nvGrpSpPr>
-      <p:grpSpPr/>
+      <p:grpSpPr>
+        <a:xfrm>
+          <a:off x="0" y="0"/>
+          <a:ext cx="0" cy="0"/>
+          <a:chOff x="0" y="0"/>
+          <a:chExt cx="0" cy="0"/>
+        </a:xfrm>
+      </p:grpSpPr>
       <p:sp>
         <p:nvSpPr>
           <p:cNvPr id="2" name="Rectangle 1"/>
@@ -8528,6 +8643,7 @@
           <a:lstStyle/>
           <a:p>
             <a:pPr algn="ctr"/>
+            <a:endParaRPr/>
           </a:p>
         </p:txBody>
       </p:sp>
@@ -8571,6 +8687,7 @@
           <a:lstStyle/>
           <a:p>
             <a:pPr algn="ctr"/>
+            <a:endParaRPr/>
           </a:p>
         </p:txBody>
       </p:sp>
@@ -8614,6 +8731,7 @@
           <a:lstStyle/>
           <a:p>
             <a:pPr algn="ctr"/>
+            <a:endParaRPr/>
           </a:p>
         </p:txBody>
       </p:sp>
@@ -8725,6 +8843,7 @@
           <a:lstStyle/>
           <a:p>
             <a:pPr algn="ctr"/>
+            <a:endParaRPr/>
           </a:p>
         </p:txBody>
       </p:sp>
@@ -8768,6 +8887,7 @@
           <a:lstStyle/>
           <a:p>
             <a:pPr algn="ctr"/>
+            <a:endParaRPr/>
           </a:p>
         </p:txBody>
       </p:sp>
@@ -8903,6 +9023,7 @@
           <a:lstStyle/>
           <a:p>
             <a:pPr algn="ctr"/>
+            <a:endParaRPr/>
           </a:p>
         </p:txBody>
       </p:sp>
@@ -8946,6 +9067,7 @@
           <a:lstStyle/>
           <a:p>
             <a:pPr algn="ctr"/>
+            <a:endParaRPr/>
           </a:p>
         </p:txBody>
       </p:sp>
@@ -9023,6 +9145,7 @@
           <a:lstStyle/>
           <a:p>
             <a:pPr algn="ctr"/>
+            <a:endParaRPr/>
           </a:p>
         </p:txBody>
       </p:sp>
@@ -9066,6 +9189,7 @@
           <a:lstStyle/>
           <a:p>
             <a:pPr algn="ctr"/>
+            <a:endParaRPr/>
           </a:p>
         </p:txBody>
       </p:sp>
@@ -9177,6 +9301,7 @@
           <a:lstStyle/>
           <a:p>
             <a:pPr algn="ctr"/>
+            <a:endParaRPr/>
           </a:p>
         </p:txBody>
       </p:sp>
@@ -9220,6 +9345,7 @@
           <a:lstStyle/>
           <a:p>
             <a:pPr algn="ctr"/>
+            <a:endParaRPr/>
           </a:p>
         </p:txBody>
       </p:sp>
@@ -9331,6 +9457,7 @@
           <a:lstStyle/>
           <a:p>
             <a:pPr algn="ctr"/>
+            <a:endParaRPr/>
           </a:p>
         </p:txBody>
       </p:sp>
@@ -9374,6 +9501,7 @@
           <a:lstStyle/>
           <a:p>
             <a:pPr algn="ctr"/>
+            <a:endParaRPr/>
           </a:p>
         </p:txBody>
       </p:sp>
@@ -9490,7 +9618,7 @@
 </file>
 
 <file path=ppt/slides/slide6.xml><?xml version="1.0" encoding="utf-8"?>
-<p:sld xmlns:a="http://schemas.openxmlformats.org/drawingml/2006/main" xmlns:p="http://schemas.openxmlformats.org/presentationml/2006/main" xmlns:r="http://schemas.openxmlformats.org/officeDocument/2006/relationships">
+<p:sld xmlns:a="http://schemas.openxmlformats.org/drawingml/2006/main" xmlns:r="http://schemas.openxmlformats.org/officeDocument/2006/relationships" xmlns:p="http://schemas.openxmlformats.org/presentationml/2006/main">
   <p:cSld>
     <p:bg>
       <p:bgPr>
@@ -9506,7 +9634,14 @@
         <p:cNvGrpSpPr/>
         <p:nvPr/>
       </p:nvGrpSpPr>
-      <p:grpSpPr/>
+      <p:grpSpPr>
+        <a:xfrm>
+          <a:off x="0" y="0"/>
+          <a:ext cx="0" cy="0"/>
+          <a:chOff x="0" y="0"/>
+          <a:chExt cx="0" cy="0"/>
+        </a:xfrm>
+      </p:grpSpPr>
       <p:sp>
         <p:nvSpPr>
           <p:cNvPr id="2" name="Rectangle 1"/>
@@ -9547,6 +9682,7 @@
           <a:lstStyle/>
           <a:p>
             <a:pPr algn="ctr"/>
+            <a:endParaRPr/>
           </a:p>
         </p:txBody>
       </p:sp>
@@ -9590,6 +9726,7 @@
           <a:lstStyle/>
           <a:p>
             <a:pPr algn="ctr"/>
+            <a:endParaRPr/>
           </a:p>
         </p:txBody>
       </p:sp>
@@ -9633,6 +9770,7 @@
           <a:lstStyle/>
           <a:p>
             <a:pPr algn="ctr"/>
+            <a:endParaRPr/>
           </a:p>
         </p:txBody>
       </p:sp>
@@ -9744,6 +9882,7 @@
           <a:lstStyle/>
           <a:p>
             <a:pPr algn="ctr"/>
+            <a:endParaRPr/>
           </a:p>
         </p:txBody>
       </p:sp>
@@ -9787,6 +9926,7 @@
           <a:lstStyle/>
           <a:p>
             <a:pPr algn="ctr"/>
+            <a:endParaRPr/>
           </a:p>
         </p:txBody>
       </p:sp>
@@ -9898,6 +10038,7 @@
           <a:lstStyle/>
           <a:p>
             <a:pPr algn="ctr"/>
+            <a:endParaRPr/>
           </a:p>
         </p:txBody>
       </p:sp>
@@ -9941,6 +10082,7 @@
           <a:lstStyle/>
           <a:p>
             <a:pPr algn="ctr"/>
+            <a:endParaRPr/>
           </a:p>
         </p:txBody>
       </p:sp>
@@ -10053,6 +10195,7 @@
           <a:lstStyle/>
           <a:p>
             <a:pPr algn="ctr"/>
+            <a:endParaRPr/>
           </a:p>
         </p:txBody>
       </p:sp>
@@ -10096,6 +10239,7 @@
           <a:lstStyle/>
           <a:p>
             <a:pPr algn="ctr"/>
+            <a:endParaRPr/>
           </a:p>
         </p:txBody>
       </p:sp>
@@ -10208,6 +10352,7 @@
           <a:lstStyle/>
           <a:p>
             <a:pPr algn="ctr"/>
+            <a:endParaRPr/>
           </a:p>
         </p:txBody>
       </p:sp>
@@ -10251,6 +10396,7 @@
           <a:lstStyle/>
           <a:p>
             <a:pPr algn="ctr"/>
+            <a:endParaRPr/>
           </a:p>
         </p:txBody>
       </p:sp>
@@ -10363,6 +10509,7 @@
           <a:lstStyle/>
           <a:p>
             <a:pPr algn="ctr"/>
+            <a:endParaRPr/>
           </a:p>
         </p:txBody>
       </p:sp>
@@ -10406,6 +10553,7 @@
           <a:lstStyle/>
           <a:p>
             <a:pPr algn="ctr"/>
+            <a:endParaRPr/>
           </a:p>
         </p:txBody>
       </p:sp>
@@ -10518,6 +10666,7 @@
           <a:lstStyle/>
           <a:p>
             <a:pPr algn="ctr"/>
+            <a:endParaRPr/>
           </a:p>
         </p:txBody>
       </p:sp>
@@ -10561,6 +10710,7 @@
           <a:lstStyle/>
           <a:p>
             <a:pPr algn="ctr"/>
+            <a:endParaRPr/>
           </a:p>
         </p:txBody>
       </p:sp>
@@ -11182,6 +11332,7 @@
           <a:lstStyle/>
           <a:p>
             <a:pPr algn="ctr"/>
+            <a:endParaRPr/>
           </a:p>
         </p:txBody>
       </p:sp>
@@ -11225,6 +11376,7 @@
           <a:lstStyle/>
           <a:p>
             <a:pPr algn="ctr"/>
+            <a:endParaRPr/>
           </a:p>
         </p:txBody>
       </p:sp>
@@ -11369,6 +11521,7 @@
                 </a:solidFill>
               </a:defRPr>
             </a:pPr>
+            <a:endParaRPr/>
           </a:p>
           <a:p>
             <a:pPr>
@@ -11441,7 +11594,7 @@
 </file>
 
 <file path=ppt/slides/slide7.xml><?xml version="1.0" encoding="utf-8"?>
-<p:sld xmlns:a="http://schemas.openxmlformats.org/drawingml/2006/main" xmlns:p="http://schemas.openxmlformats.org/presentationml/2006/main" xmlns:r="http://schemas.openxmlformats.org/officeDocument/2006/relationships">
+<p:sld xmlns:a="http://schemas.openxmlformats.org/drawingml/2006/main" xmlns:r="http://schemas.openxmlformats.org/officeDocument/2006/relationships" xmlns:p="http://schemas.openxmlformats.org/presentationml/2006/main">
   <p:cSld>
     <p:bg>
       <p:bgPr>
@@ -11457,7 +11610,14 @@
         <p:cNvGrpSpPr/>
         <p:nvPr/>
       </p:nvGrpSpPr>
-      <p:grpSpPr/>
+      <p:grpSpPr>
+        <a:xfrm>
+          <a:off x="0" y="0"/>
+          <a:ext cx="0" cy="0"/>
+          <a:chOff x="0" y="0"/>
+          <a:chExt cx="0" cy="0"/>
+        </a:xfrm>
+      </p:grpSpPr>
       <p:sp>
         <p:nvSpPr>
           <p:cNvPr id="2" name="Rectangle 1"/>
@@ -11498,6 +11658,7 @@
           <a:lstStyle/>
           <a:p>
             <a:pPr algn="ctr"/>
+            <a:endParaRPr/>
           </a:p>
         </p:txBody>
       </p:sp>
@@ -11541,6 +11702,7 @@
           <a:lstStyle/>
           <a:p>
             <a:pPr algn="ctr"/>
+            <a:endParaRPr/>
           </a:p>
         </p:txBody>
       </p:sp>
@@ -11584,6 +11746,7 @@
           <a:lstStyle/>
           <a:p>
             <a:pPr algn="ctr"/>
+            <a:endParaRPr/>
           </a:p>
         </p:txBody>
       </p:sp>
@@ -11695,6 +11858,7 @@
           <a:lstStyle/>
           <a:p>
             <a:pPr algn="ctr"/>
+            <a:endParaRPr/>
           </a:p>
         </p:txBody>
       </p:sp>
@@ -11738,6 +11902,7 @@
           <a:lstStyle/>
           <a:p>
             <a:pPr algn="ctr"/>
+            <a:endParaRPr/>
           </a:p>
         </p:txBody>
       </p:sp>
@@ -11849,6 +12014,7 @@
           <a:lstStyle/>
           <a:p>
             <a:pPr algn="ctr"/>
+            <a:endParaRPr/>
           </a:p>
         </p:txBody>
       </p:sp>
@@ -11892,6 +12058,7 @@
           <a:lstStyle/>
           <a:p>
             <a:pPr algn="ctr"/>
+            <a:endParaRPr/>
           </a:p>
         </p:txBody>
       </p:sp>
@@ -12003,6 +12170,7 @@
           <a:lstStyle/>
           <a:p>
             <a:pPr algn="ctr"/>
+            <a:endParaRPr/>
           </a:p>
         </p:txBody>
       </p:sp>
@@ -12046,6 +12214,7 @@
           <a:lstStyle/>
           <a:p>
             <a:pPr algn="ctr"/>
+            <a:endParaRPr/>
           </a:p>
         </p:txBody>
       </p:sp>
@@ -12157,6 +12326,7 @@
           <a:lstStyle/>
           <a:p>
             <a:pPr algn="ctr"/>
+            <a:endParaRPr/>
           </a:p>
         </p:txBody>
       </p:sp>
@@ -12200,6 +12370,7 @@
           <a:lstStyle/>
           <a:p>
             <a:pPr algn="ctr"/>
+            <a:endParaRPr/>
           </a:p>
         </p:txBody>
       </p:sp>
@@ -12311,6 +12482,7 @@
           <a:lstStyle/>
           <a:p>
             <a:pPr algn="ctr"/>
+            <a:endParaRPr/>
           </a:p>
         </p:txBody>
       </p:sp>
@@ -12354,6 +12526,7 @@
           <a:lstStyle/>
           <a:p>
             <a:pPr algn="ctr"/>
+            <a:endParaRPr/>
           </a:p>
         </p:txBody>
       </p:sp>
@@ -12489,6 +12662,7 @@
           <a:lstStyle/>
           <a:p>
             <a:pPr algn="ctr"/>
+            <a:endParaRPr/>
           </a:p>
         </p:txBody>
       </p:sp>
@@ -12532,6 +12706,7 @@
           <a:lstStyle/>
           <a:p>
             <a:pPr algn="ctr"/>
+            <a:endParaRPr/>
           </a:p>
         </p:txBody>
       </p:sp>
@@ -12592,14 +12767,7 @@
           <a:lstStyle/>
           <a:p>
             <a:pPr algn="ctr"/>
-            <a:r>
-              <a:rPr sz="1300" b="0" i="0">
-                <a:solidFill>
-                  <a:srgbClr val="9FB6CF"/>
-                </a:solidFill>
-              </a:rPr>
-              <a:t/>
-            </a:r>
+            <a:endParaRPr/>
           </a:p>
         </p:txBody>
       </p:sp>
@@ -12967,7 +13135,7 @@
 </file>
 
 <file path=ppt/slides/slide8.xml><?xml version="1.0" encoding="utf-8"?>
-<p:sld xmlns:a="http://schemas.openxmlformats.org/drawingml/2006/main" xmlns:p="http://schemas.openxmlformats.org/presentationml/2006/main" xmlns:r="http://schemas.openxmlformats.org/officeDocument/2006/relationships">
+<p:sld xmlns:a="http://schemas.openxmlformats.org/drawingml/2006/main" xmlns:r="http://schemas.openxmlformats.org/officeDocument/2006/relationships" xmlns:p="http://schemas.openxmlformats.org/presentationml/2006/main">
   <p:cSld>
     <p:bg>
       <p:bgPr>
@@ -12983,7 +13151,14 @@
         <p:cNvGrpSpPr/>
         <p:nvPr/>
       </p:nvGrpSpPr>
-      <p:grpSpPr/>
+      <p:grpSpPr>
+        <a:xfrm>
+          <a:off x="0" y="0"/>
+          <a:ext cx="0" cy="0"/>
+          <a:chOff x="0" y="0"/>
+          <a:chExt cx="0" cy="0"/>
+        </a:xfrm>
+      </p:grpSpPr>
       <p:sp>
         <p:nvSpPr>
           <p:cNvPr id="2" name="Rectangle 1"/>
@@ -13024,6 +13199,7 @@
           <a:lstStyle/>
           <a:p>
             <a:pPr algn="ctr"/>
+            <a:endParaRPr/>
           </a:p>
         </p:txBody>
       </p:sp>
@@ -13067,6 +13243,7 @@
           <a:lstStyle/>
           <a:p>
             <a:pPr algn="ctr"/>
+            <a:endParaRPr/>
           </a:p>
         </p:txBody>
       </p:sp>
@@ -13110,6 +13287,7 @@
           <a:lstStyle/>
           <a:p>
             <a:pPr algn="ctr"/>
+            <a:endParaRPr/>
           </a:p>
         </p:txBody>
       </p:sp>
@@ -13221,6 +13399,7 @@
           <a:lstStyle/>
           <a:p>
             <a:pPr algn="ctr"/>
+            <a:endParaRPr/>
           </a:p>
         </p:txBody>
       </p:sp>
@@ -13264,6 +13443,7 @@
           <a:lstStyle/>
           <a:p>
             <a:pPr algn="ctr"/>
+            <a:endParaRPr/>
           </a:p>
         </p:txBody>
       </p:sp>
@@ -13399,6 +13579,7 @@
           <a:lstStyle/>
           <a:p>
             <a:pPr algn="ctr"/>
+            <a:endParaRPr/>
           </a:p>
         </p:txBody>
       </p:sp>
@@ -13442,6 +13623,7 @@
           <a:lstStyle/>
           <a:p>
             <a:pPr algn="ctr"/>
+            <a:endParaRPr/>
           </a:p>
         </p:txBody>
       </p:sp>
@@ -13571,6 +13753,7 @@
                 </a:solidFill>
               </a:defRPr>
             </a:pPr>
+            <a:endParaRPr/>
           </a:p>
           <a:p>
             <a:pPr>
@@ -13643,6 +13826,7 @@
                 </a:solidFill>
               </a:defRPr>
             </a:pPr>
+            <a:endParaRPr/>
           </a:p>
           <a:p>
             <a:pPr>
@@ -13685,7 +13869,7 @@
 </file>
 
 <file path=ppt/slides/slide9.xml><?xml version="1.0" encoding="utf-8"?>
-<p:sld xmlns:a="http://schemas.openxmlformats.org/drawingml/2006/main" xmlns:p="http://schemas.openxmlformats.org/presentationml/2006/main" xmlns:r="http://schemas.openxmlformats.org/officeDocument/2006/relationships">
+<p:sld xmlns:a="http://schemas.openxmlformats.org/drawingml/2006/main" xmlns:r="http://schemas.openxmlformats.org/officeDocument/2006/relationships" xmlns:p="http://schemas.openxmlformats.org/presentationml/2006/main">
   <p:cSld>
     <p:bg>
       <p:bgPr>
@@ -13701,7 +13885,14 @@
         <p:cNvGrpSpPr/>
         <p:nvPr/>
       </p:nvGrpSpPr>
-      <p:grpSpPr/>
+      <p:grpSpPr>
+        <a:xfrm>
+          <a:off x="0" y="0"/>
+          <a:ext cx="0" cy="0"/>
+          <a:chOff x="0" y="0"/>
+          <a:chExt cx="0" cy="0"/>
+        </a:xfrm>
+      </p:grpSpPr>
       <p:sp>
         <p:nvSpPr>
           <p:cNvPr id="2" name="Rectangle 1"/>
@@ -13742,6 +13933,7 @@
           <a:lstStyle/>
           <a:p>
             <a:pPr algn="ctr"/>
+            <a:endParaRPr/>
           </a:p>
         </p:txBody>
       </p:sp>
@@ -13785,6 +13977,7 @@
           <a:lstStyle/>
           <a:p>
             <a:pPr algn="ctr"/>
+            <a:endParaRPr/>
           </a:p>
         </p:txBody>
       </p:sp>
@@ -13828,6 +14021,7 @@
           <a:lstStyle/>
           <a:p>
             <a:pPr algn="ctr"/>
+            <a:endParaRPr/>
           </a:p>
         </p:txBody>
       </p:sp>
@@ -13939,6 +14133,7 @@
           <a:lstStyle/>
           <a:p>
             <a:pPr algn="ctr"/>
+            <a:endParaRPr/>
           </a:p>
         </p:txBody>
       </p:sp>
@@ -13982,6 +14177,7 @@
           <a:lstStyle/>
           <a:p>
             <a:pPr algn="ctr"/>
+            <a:endParaRPr/>
           </a:p>
         </p:txBody>
       </p:sp>
@@ -14117,6 +14313,7 @@
           <a:lstStyle/>
           <a:p>
             <a:pPr algn="ctr"/>
+            <a:endParaRPr/>
           </a:p>
         </p:txBody>
       </p:sp>
@@ -14160,6 +14357,7 @@
           <a:lstStyle/>
           <a:p>
             <a:pPr algn="ctr"/>
+            <a:endParaRPr/>
           </a:p>
         </p:txBody>
       </p:sp>
@@ -14289,6 +14487,7 @@
                 </a:solidFill>
               </a:defRPr>
             </a:pPr>
+            <a:endParaRPr/>
           </a:p>
           <a:p>
             <a:pPr>
@@ -14376,6 +14575,7 @@
                 </a:solidFill>
               </a:defRPr>
             </a:pPr>
+            <a:endParaRPr/>
           </a:p>
           <a:p>
             <a:pPr>

</xml_diff>